<commit_message>
Manuel chef de projet : galerie média de la vitrine
- Nouvelle page « La galerie média : images, vidéos et sons » (partie 3) : poignée
  de taille, carrousel, médias et légendes, vue visiteur, vidéo Microsoft Stream et
  partage nécessaire.
- « Ajouter une section » : capture du sélecteur mise à jour et gabarit ajouté à la liste.
- Intercalaire de la partie 3 et « Entrées par objectif » : lien vers la nouvelle page.
- « Bon à savoir sur le questionnaire » : chaque projet a désormais sa vitrine.

Co-Authored-By: Claude Opus 5.5 <noreply@anthropic.com>
Claude-Session: https://claude.ai/code/session_013ggHK1CDXnG5bFYyYmTXJ5
</commit_message>
<xml_diff>
--- a/docs/Project Navigator _ Manuel Chef de Project.pptx
+++ b/docs/Project Navigator _ Manuel Chef de Project.pptx
@@ -38,6 +38,7 @@
     <p:sldId id="277" r:id="rId29"/>
     <p:sldId id="278" r:id="rId30"/>
     <p:sldId id="279" r:id="rId31"/>
+    <p:sldId id="321" r:id="rId72"/>
     <p:sldId id="280" r:id="rId32"/>
     <p:sldId id="281" r:id="rId33"/>
     <p:sldId id="282" r:id="rId34"/>
@@ -20741,7 +20742,7 @@
                 </a:solidFill>
                 <a:latin typeface="Roboto"/>
               </a:rPr>
-              <a:t>Pour certains types de projet, la vitrine n’est pas proposée : la fin du questionnaire mène alors directement aux enjeux du projet.</a:t>
+              <a:t>Chaque projet a sa vitrine : selon son type, elle peut partir d’un modèle qui propose déjà ses sections.</a:t>
             </a:r>
           </a:p>
         </p:txBody>
@@ -21218,6 +21219,43 @@
       </p:sp>
       <p:sp>
         <p:nvSpPr>
+          <p:cNvPr id="19" name="TextBox 16">
+            <a:hlinkClick r:id="rId8" action="ppaction://hlinksldjump"/>
+          </p:cNvPr>
+          <p:cNvSpPr txBox="1"/>
+          <p:nvPr/>
+        </p:nvSpPr>
+        <p:spPr>
+          <a:xfrm>
+            <a:off x="6629400" y="2473959"/>
+            <a:ext cx="1691640" cy="329184"/>
+          </a:xfrm>
+          <a:prstGeom prst="rect">
+            <a:avLst/>
+          </a:prstGeom>
+          <a:noFill/>
+        </p:spPr>
+        <p:txBody>
+          <a:bodyPr wrap="square" lIns="0" tIns="0" rIns="0" bIns="0" anchor="t">
+            <a:spAutoFit/>
+          </a:bodyPr>
+          <a:lstStyle/>
+          <a:p>
+            <a:pPr algn="l"/>
+            <a:r>
+              <a:rPr sz="950" b="0" i="0">
+                <a:solidFill>
+                  <a:srgbClr val="003059"/>
+                </a:solidFill>
+                <a:latin typeface="Roboto"/>
+              </a:rPr>
+              <a:t>La galerie média</a:t>
+            </a:r>
+          </a:p>
+        </p:txBody>
+      </p:sp>
+      <p:sp>
+        <p:nvSpPr>
           <p:cNvPr id="15" name="TextBox 14">
             <a:hlinkClick r:id="rId7" action="ppaction://hlinksldjump"/>
           </p:cNvPr>
@@ -21226,7 +21264,7 @@
         </p:nvSpPr>
         <p:spPr>
           <a:xfrm>
-            <a:off x="6629400" y="2473959"/>
+            <a:off x="6629400" y="2738118"/>
             <a:ext cx="1691640" cy="329184"/>
           </a:xfrm>
           <a:prstGeom prst="rect">
@@ -21249,6 +21287,43 @@
                 <a:latin typeface="Roboto"/>
               </a:rPr>
               <a:t>Aperçu et publication</a:t>
+            </a:r>
+          </a:p>
+        </p:txBody>
+      </p:sp>
+      <p:sp>
+        <p:nvSpPr>
+          <p:cNvPr id="20" name="TextBox 17">
+            <a:hlinkClick r:id="rId8" action="ppaction://hlinksldjump"/>
+          </p:cNvPr>
+          <p:cNvSpPr txBox="1"/>
+          <p:nvPr/>
+        </p:nvSpPr>
+        <p:spPr>
+          <a:xfrm>
+            <a:off x="8321040" y="2473959"/>
+            <a:ext cx="320040" cy="182880"/>
+          </a:xfrm>
+          <a:prstGeom prst="rect">
+            <a:avLst/>
+          </a:prstGeom>
+          <a:noFill/>
+        </p:spPr>
+        <p:txBody>
+          <a:bodyPr wrap="square" lIns="0" tIns="0" rIns="0" bIns="0" anchor="t">
+            <a:spAutoFit/>
+          </a:bodyPr>
+          <a:lstStyle/>
+          <a:p>
+            <a:pPr algn="r"/>
+            <a:r>
+              <a:rPr sz="950" b="1" i="0">
+                <a:solidFill>
+                  <a:srgbClr val="996B14"/>
+                </a:solidFill>
+                <a:latin typeface="Roboto"/>
+              </a:rPr>
+              <a:t>→</a:t>
             </a:r>
           </a:p>
         </p:txBody>
@@ -21263,7 +21338,7 @@
         </p:nvSpPr>
         <p:spPr>
           <a:xfrm>
-            <a:off x="8321040" y="2473959"/>
+            <a:off x="8321040" y="2738118"/>
             <a:ext cx="320040" cy="182880"/>
           </a:xfrm>
           <a:prstGeom prst="rect">
@@ -23122,7 +23197,7 @@
       </p:pic>
       <p:pic>
         <p:nvPicPr>
-          <p:cNvPr id="7" name="Picture 6" descr="24-sc-picker_976.jpg"/>
+          <p:cNvPr id="7" name="Picture 6" descr="Sélecteur de gabarits, avec la galerie média"/>
           <p:cNvPicPr>
             <a:picLocks noChangeAspect="1"/>
           </p:cNvPicPr>
@@ -23137,7 +23212,7 @@
         <p:spPr>
           <a:xfrm>
             <a:off x="548640" y="2331720"/>
-            <a:ext cx="3718684" cy="2377440"/>
+            <a:ext cx="3718684" cy="2324178"/>
           </a:xfrm>
           <a:prstGeom prst="rect">
             <a:avLst/>
@@ -23741,6 +23816,86 @@
                 <a:latin typeface="Roboto"/>
               </a:rPr>
               <a:t>Bloc narratif · Points d’attention</a:t>
+            </a:r>
+          </a:p>
+        </p:txBody>
+      </p:sp>
+      <p:sp>
+        <p:nvSpPr>
+          <p:cNvPr id="22" name="Oval 21"/>
+          <p:cNvSpPr/>
+          <p:nvPr/>
+        </p:nvSpPr>
+        <p:spPr>
+          <a:xfrm>
+            <a:off x="4809744" y="4050284"/>
+            <a:ext cx="73152" cy="73152"/>
+          </a:xfrm>
+          <a:prstGeom prst="ellipse">
+            <a:avLst/>
+          </a:prstGeom>
+          <a:solidFill>
+            <a:srgbClr val="0061B0"/>
+          </a:solidFill>
+          <a:ln>
+            <a:noFill/>
+          </a:ln>
+          <a:effectLst/>
+        </p:spPr>
+        <p:style>
+          <a:lnRef idx="1">
+            <a:schemeClr val="accent1"/>
+          </a:lnRef>
+          <a:fillRef idx="3">
+            <a:schemeClr val="accent1"/>
+          </a:fillRef>
+          <a:effectRef idx="0">
+            <a:schemeClr val="accent1"/>
+          </a:effectRef>
+          <a:fontRef idx="minor">
+            <a:schemeClr val="lt1"/>
+          </a:fontRef>
+        </p:style>
+        <p:txBody>
+          <a:bodyPr rtlCol="0" anchor="ctr"/>
+          <a:lstStyle/>
+          <a:p>
+            <a:pPr algn="ctr"/>
+            <a:endParaRPr/>
+          </a:p>
+        </p:txBody>
+      </p:sp>
+      <p:sp>
+        <p:nvSpPr>
+          <p:cNvPr id="23" name="TextBox 22"/>
+          <p:cNvSpPr txBox="1"/>
+          <p:nvPr/>
+        </p:nvSpPr>
+        <p:spPr>
+          <a:xfrm>
+            <a:off x="4992624" y="3996944"/>
+            <a:ext cx="3456432" cy="162560"/>
+          </a:xfrm>
+          <a:prstGeom prst="rect">
+            <a:avLst/>
+          </a:prstGeom>
+          <a:noFill/>
+        </p:spPr>
+        <p:txBody>
+          <a:bodyPr wrap="square" lIns="0" tIns="0" rIns="0" bIns="0" anchor="t">
+            <a:spAutoFit/>
+          </a:bodyPr>
+          <a:lstStyle/>
+          <a:p>
+            <a:pPr algn="l"/>
+            <a:r>
+              <a:rPr sz="1000" b="0" i="0">
+                <a:solidFill>
+                  <a:srgbClr val="1F2A37"/>
+                </a:solidFill>
+                <a:latin typeface="Roboto"/>
+              </a:rPr>
+              <a:t>Galerie média : images, vidéos, sons, Stream</a:t>
             </a:r>
           </a:p>
         </p:txBody>
@@ -49943,6 +50098,746 @@
 </p:sld>
 </file>
 
+<file path=ppt/slides/slide59.xml><?xml version="1.0" encoding="utf-8"?>
+<p:sld xmlns:a="http://schemas.openxmlformats.org/drawingml/2006/main" xmlns:r="http://schemas.openxmlformats.org/officeDocument/2006/relationships" xmlns:p="http://schemas.openxmlformats.org/presentationml/2006/main">
+  <p:cSld>
+    <p:spTree>
+      <p:nvGrpSpPr>
+        <p:cNvPr id="1" name=""/>
+        <p:cNvGrpSpPr/>
+        <p:nvPr/>
+      </p:nvGrpSpPr>
+      <p:grpSpPr>
+        <a:xfrm>
+          <a:off x="0" y="0"/>
+          <a:ext cx="0" cy="0"/>
+          <a:chOff x="0" y="0"/>
+          <a:chExt cx="0" cy="0"/>
+        </a:xfrm>
+      </p:grpSpPr>
+      <p:sp>
+        <p:nvSpPr>
+          <p:cNvPr id="2" name="Title 1"/>
+          <p:cNvSpPr>
+            <a:spLocks noGrp="1"/>
+          </p:cNvSpPr>
+          <p:nvPr>
+            <p:ph type="title"/>
+          </p:nvPr>
+        </p:nvSpPr>
+        <p:spPr/>
+        <p:txBody>
+          <a:bodyPr/>
+          <a:lstStyle/>
+          <a:p>
+            <a:r>
+              <a:t>La galerie média : images, vidéos et sons</a:t>
+            </a:r>
+          </a:p>
+        </p:txBody>
+      </p:sp>
+      <p:sp>
+        <p:nvSpPr>
+          <p:cNvPr id="4" name="Espace réservé du pied de page 3">
+            <a:extLst>
+              <a:ext uri="{FF2B5EF4-FFF2-40B4-BE49-F238E27FC236}">
+                <a16:creationId xmlns:a16="http://schemas.microsoft.com/office/drawing/2014/main" id="{D77D12DE-AC0B-DC1C-8701-434038699D7A}"/>
+              </a:ext>
+            </a:extLst>
+          </p:cNvPr>
+          <p:cNvSpPr>
+            <a:spLocks noGrp="1"/>
+          </p:cNvSpPr>
+          <p:nvPr>
+            <p:ph type="ftr" sz="quarter" idx="11"/>
+          </p:nvPr>
+        </p:nvSpPr>
+        <p:spPr/>
+        <p:txBody>
+          <a:bodyPr/>
+          <a:lstStyle/>
+          <a:p>
+            <a:r>
+              <a:rPr lang="fr-FR" sz="800">
+                <a:latin typeface="Roboto"/>
+              </a:rPr>
+              <a:t>03 · La vitrine du projet</a:t>
+            </a:r>
+          </a:p>
+        </p:txBody>
+      </p:sp>
+      <p:sp>
+        <p:nvSpPr>
+          <p:cNvPr id="5" name="TextBox 4">
+            <a:hlinkClick r:id="rId2" action="ppaction://hlinksldjump"/>
+          </p:cNvPr>
+          <p:cNvSpPr txBox="1"/>
+          <p:nvPr/>
+        </p:nvSpPr>
+        <p:spPr>
+          <a:xfrm>
+            <a:off x="7543800" y="164592"/>
+            <a:ext cx="1097280" cy="201168"/>
+          </a:xfrm>
+          <a:prstGeom prst="rect">
+            <a:avLst/>
+          </a:prstGeom>
+          <a:noFill/>
+        </p:spPr>
+        <p:txBody>
+          <a:bodyPr wrap="square" lIns="0" tIns="0" rIns="0" bIns="0" anchor="t">
+            <a:spAutoFit/>
+          </a:bodyPr>
+          <a:lstStyle/>
+          <a:p>
+            <a:pPr algn="r"/>
+            <a:r>
+              <a:rPr sz="800" b="0" i="0">
+                <a:solidFill>
+                  <a:srgbClr val="0061B0"/>
+                </a:solidFill>
+                <a:latin typeface="Roboto"/>
+              </a:rPr>
+              <a:t>← Sommaire</a:t>
+            </a:r>
+          </a:p>
+        </p:txBody>
+      </p:sp>
+      <p:pic>
+        <p:nvPicPr>
+          <p:cNvPr id="6" name="Picture 5" descr="Galerie média en mode édition"/>
+          <p:cNvPicPr>
+            <a:picLocks noChangeAspect="1"/>
+          </p:cNvPicPr>
+          <p:nvPr/>
+        </p:nvPicPr>
+        <p:blipFill>
+          <a:blip r:embed="rId3"/>
+          <a:stretch>
+            <a:fillRect/>
+          </a:stretch>
+        </p:blipFill>
+        <p:spPr>
+          <a:xfrm>
+            <a:off x="548640" y="1188720"/>
+            <a:ext cx="3474720" cy="2171700"/>
+          </a:xfrm>
+          <a:prstGeom prst="rect">
+            <a:avLst/>
+          </a:prstGeom>
+          <a:ln w="9525">
+            <a:solidFill>
+              <a:srgbClr val="D5DCE4"/>
+            </a:solidFill>
+          </a:ln>
+        </p:spPr>
+      </p:pic>
+      <p:sp>
+        <p:nvSpPr>
+          <p:cNvPr id="10" name="Oval 9"/>
+          <p:cNvSpPr/>
+          <p:nvPr/>
+        </p:nvSpPr>
+        <p:spPr>
+          <a:xfrm>
+            <a:off x="548640" y="3451860"/>
+            <a:ext cx="237744" cy="237744"/>
+          </a:xfrm>
+          <a:prstGeom prst="ellipse">
+            <a:avLst/>
+          </a:prstGeom>
+          <a:solidFill>
+            <a:srgbClr val="C8102E"/>
+          </a:solidFill>
+          <a:ln>
+            <a:noFill/>
+          </a:ln>
+          <a:effectLst/>
+        </p:spPr>
+        <p:style>
+          <a:lnRef idx="1">
+            <a:schemeClr val="accent1"/>
+          </a:lnRef>
+          <a:fillRef idx="3">
+            <a:schemeClr val="accent1"/>
+          </a:fillRef>
+          <a:effectRef idx="0">
+            <a:schemeClr val="accent1"/>
+          </a:effectRef>
+          <a:fontRef idx="minor">
+            <a:schemeClr val="lt1"/>
+          </a:fontRef>
+        </p:style>
+        <p:txBody>
+          <a:bodyPr lIns="0" tIns="0" rIns="0" bIns="0" rtlCol="0" anchor="ctr"/>
+          <a:lstStyle/>
+          <a:p>
+            <a:pPr algn="ctr"/>
+            <a:r>
+              <a:rPr lang="fr-FR" sz="1000" b="1">
+                <a:solidFill>
+                  <a:srgbClr val="FFFFFF"/>
+                </a:solidFill>
+                <a:latin typeface="Roboto"/>
+              </a:rPr>
+              <a:t>1</a:t>
+            </a:r>
+          </a:p>
+        </p:txBody>
+      </p:sp>
+      <p:sp>
+        <p:nvSpPr>
+          <p:cNvPr id="11" name="TextBox 10"/>
+          <p:cNvSpPr txBox="1"/>
+          <p:nvPr/>
+        </p:nvSpPr>
+        <p:spPr>
+          <a:xfrm>
+            <a:off x="877824" y="3488436"/>
+            <a:ext cx="3328416" cy="308864"/>
+          </a:xfrm>
+          <a:prstGeom prst="rect">
+            <a:avLst/>
+          </a:prstGeom>
+          <a:noFill/>
+        </p:spPr>
+        <p:txBody>
+          <a:bodyPr wrap="square" lIns="0" tIns="0" rIns="0" bIns="0" anchor="t">
+            <a:spAutoFit/>
+          </a:bodyPr>
+          <a:lstStyle/>
+          <a:p>
+            <a:pPr algn="l"/>
+            <a:r>
+              <a:rPr lang="fr-FR" sz="950" b="1" i="0" dirty="0">
+                <a:solidFill>
+                  <a:srgbClr val="1F2A37"/>
+                </a:solidFill>
+                <a:latin typeface="Roboto"/>
+              </a:rPr>
+              <a:t xml:space="preserve">Poignée</a:t>
+            </a:r>
+            <a:r>
+              <a:rPr lang="fr-FR" sz="950" b="0" i="0" dirty="0">
+                <a:solidFill>
+                  <a:srgbClr val="1F2A37"/>
+                </a:solidFill>
+                <a:latin typeface="Roboto"/>
+              </a:rPr>
+              <a:t xml:space="preserve"> : glissez-la pour régler la taille du média, les proportions sont conservées.</a:t>
+            </a:r>
+          </a:p>
+        </p:txBody>
+      </p:sp>
+      <p:sp>
+        <p:nvSpPr>
+          <p:cNvPr id="12" name="Oval 11"/>
+          <p:cNvSpPr/>
+          <p:nvPr/>
+        </p:nvSpPr>
+        <p:spPr>
+          <a:xfrm>
+            <a:off x="548640" y="3762756"/>
+            <a:ext cx="237744" cy="237744"/>
+          </a:xfrm>
+          <a:prstGeom prst="ellipse">
+            <a:avLst/>
+          </a:prstGeom>
+          <a:solidFill>
+            <a:srgbClr val="C8102E"/>
+          </a:solidFill>
+          <a:ln>
+            <a:noFill/>
+          </a:ln>
+          <a:effectLst/>
+        </p:spPr>
+        <p:style>
+          <a:lnRef idx="1">
+            <a:schemeClr val="accent1"/>
+          </a:lnRef>
+          <a:fillRef idx="3">
+            <a:schemeClr val="accent1"/>
+          </a:fillRef>
+          <a:effectRef idx="0">
+            <a:schemeClr val="accent1"/>
+          </a:effectRef>
+          <a:fontRef idx="minor">
+            <a:schemeClr val="lt1"/>
+          </a:fontRef>
+        </p:style>
+        <p:txBody>
+          <a:bodyPr lIns="0" tIns="0" rIns="0" bIns="0" rtlCol="0" anchor="ctr"/>
+          <a:lstStyle/>
+          <a:p>
+            <a:pPr algn="ctr"/>
+            <a:r>
+              <a:rPr lang="fr-FR" sz="1000" b="1">
+                <a:solidFill>
+                  <a:srgbClr val="FFFFFF"/>
+                </a:solidFill>
+                <a:latin typeface="Roboto"/>
+              </a:rPr>
+              <a:t>2</a:t>
+            </a:r>
+          </a:p>
+        </p:txBody>
+      </p:sp>
+      <p:sp>
+        <p:nvSpPr>
+          <p:cNvPr id="13" name="TextBox 12"/>
+          <p:cNvSpPr txBox="1"/>
+          <p:nvPr/>
+        </p:nvSpPr>
+        <p:spPr>
+          <a:xfrm>
+            <a:off x="877824" y="3799332"/>
+            <a:ext cx="3328416" cy="308864"/>
+          </a:xfrm>
+          <a:prstGeom prst="rect">
+            <a:avLst/>
+          </a:prstGeom>
+          <a:noFill/>
+        </p:spPr>
+        <p:txBody>
+          <a:bodyPr wrap="square" lIns="0" tIns="0" rIns="0" bIns="0" anchor="t">
+            <a:spAutoFit/>
+          </a:bodyPr>
+          <a:lstStyle/>
+          <a:p>
+            <a:pPr algn="l"/>
+            <a:r>
+              <a:rPr lang="fr-FR" sz="950" b="1" i="0" dirty="0">
+                <a:solidFill>
+                  <a:srgbClr val="1F2A37"/>
+                </a:solidFill>
+                <a:latin typeface="Roboto"/>
+              </a:rPr>
+              <a:t xml:space="preserve">Carrousel</a:t>
+            </a:r>
+            <a:r>
+              <a:rPr lang="fr-FR" sz="950" b="0" i="0" dirty="0">
+                <a:solidFill>
+                  <a:srgbClr val="1F2A37"/>
+                </a:solidFill>
+                <a:latin typeface="Roboto"/>
+              </a:rPr>
+              <a:t xml:space="preserve"> dès deux médias : flèches et points, il ne défile qu’au clic.</a:t>
+            </a:r>
+          </a:p>
+        </p:txBody>
+      </p:sp>
+      <p:sp>
+        <p:nvSpPr>
+          <p:cNvPr id="14" name="Oval 13"/>
+          <p:cNvSpPr/>
+          <p:nvPr/>
+        </p:nvSpPr>
+        <p:spPr>
+          <a:xfrm>
+            <a:off x="548640" y="4073652"/>
+            <a:ext cx="237744" cy="237744"/>
+          </a:xfrm>
+          <a:prstGeom prst="ellipse">
+            <a:avLst/>
+          </a:prstGeom>
+          <a:solidFill>
+            <a:srgbClr val="C8102E"/>
+          </a:solidFill>
+          <a:ln>
+            <a:noFill/>
+          </a:ln>
+          <a:effectLst/>
+        </p:spPr>
+        <p:style>
+          <a:lnRef idx="1">
+            <a:schemeClr val="accent1"/>
+          </a:lnRef>
+          <a:fillRef idx="3">
+            <a:schemeClr val="accent1"/>
+          </a:fillRef>
+          <a:effectRef idx="0">
+            <a:schemeClr val="accent1"/>
+          </a:effectRef>
+          <a:fontRef idx="minor">
+            <a:schemeClr val="lt1"/>
+          </a:fontRef>
+        </p:style>
+        <p:txBody>
+          <a:bodyPr lIns="0" tIns="0" rIns="0" bIns="0" rtlCol="0" anchor="ctr"/>
+          <a:lstStyle/>
+          <a:p>
+            <a:pPr algn="ctr"/>
+            <a:r>
+              <a:rPr lang="fr-FR" sz="1000" b="1">
+                <a:solidFill>
+                  <a:srgbClr val="FFFFFF"/>
+                </a:solidFill>
+                <a:latin typeface="Roboto"/>
+              </a:rPr>
+              <a:t>3</a:t>
+            </a:r>
+          </a:p>
+        </p:txBody>
+      </p:sp>
+      <p:sp>
+        <p:nvSpPr>
+          <p:cNvPr id="15" name="TextBox 14"/>
+          <p:cNvSpPr txBox="1"/>
+          <p:nvPr/>
+        </p:nvSpPr>
+        <p:spPr>
+          <a:xfrm>
+            <a:off x="877824" y="4110228"/>
+            <a:ext cx="3328416" cy="308864"/>
+          </a:xfrm>
+          <a:prstGeom prst="rect">
+            <a:avLst/>
+          </a:prstGeom>
+          <a:noFill/>
+        </p:spPr>
+        <p:txBody>
+          <a:bodyPr wrap="square" lIns="0" tIns="0" rIns="0" bIns="0" anchor="t">
+            <a:spAutoFit/>
+          </a:bodyPr>
+          <a:lstStyle/>
+          <a:p>
+            <a:pPr algn="l"/>
+            <a:r>
+              <a:rPr lang="fr-FR" sz="950" b="1" i="0" dirty="0">
+                <a:solidFill>
+                  <a:srgbClr val="1F2A37"/>
+                </a:solidFill>
+                <a:latin typeface="Roboto"/>
+              </a:rPr>
+              <a:t xml:space="preserve">Médias</a:t>
+            </a:r>
+            <a:r>
+              <a:rPr lang="fr-FR" sz="950" b="0" i="0" dirty="0">
+                <a:solidFill>
+                  <a:srgbClr val="1F2A37"/>
+                </a:solidFill>
+                <a:latin typeface="Roboto"/>
+              </a:rPr>
+              <a:t xml:space="preserve"> : réordonnez (↑ ↓), retirez, et légendez chacun si besoin.</a:t>
+            </a:r>
+          </a:p>
+        </p:txBody>
+      </p:sp>
+      <p:sp>
+        <p:nvSpPr>
+          <p:cNvPr id="16" name="Oval 15"/>
+          <p:cNvSpPr/>
+          <p:nvPr/>
+        </p:nvSpPr>
+        <p:spPr>
+          <a:xfrm>
+            <a:off x="548640" y="4384548"/>
+            <a:ext cx="237744" cy="237744"/>
+          </a:xfrm>
+          <a:prstGeom prst="ellipse">
+            <a:avLst/>
+          </a:prstGeom>
+          <a:solidFill>
+            <a:srgbClr val="C8102E"/>
+          </a:solidFill>
+          <a:ln>
+            <a:noFill/>
+          </a:ln>
+          <a:effectLst/>
+        </p:spPr>
+        <p:style>
+          <a:lnRef idx="1">
+            <a:schemeClr val="accent1"/>
+          </a:lnRef>
+          <a:fillRef idx="3">
+            <a:schemeClr val="accent1"/>
+          </a:fillRef>
+          <a:effectRef idx="0">
+            <a:schemeClr val="accent1"/>
+          </a:effectRef>
+          <a:fontRef idx="minor">
+            <a:schemeClr val="lt1"/>
+          </a:fontRef>
+        </p:style>
+        <p:txBody>
+          <a:bodyPr lIns="0" tIns="0" rIns="0" bIns="0" rtlCol="0" anchor="ctr"/>
+          <a:lstStyle/>
+          <a:p>
+            <a:pPr algn="ctr"/>
+            <a:r>
+              <a:rPr lang="fr-FR" sz="1000" b="1">
+                <a:solidFill>
+                  <a:srgbClr val="FFFFFF"/>
+                </a:solidFill>
+                <a:latin typeface="Roboto"/>
+              </a:rPr>
+              <a:t>4</a:t>
+            </a:r>
+          </a:p>
+        </p:txBody>
+      </p:sp>
+      <p:sp>
+        <p:nvSpPr>
+          <p:cNvPr id="17" name="TextBox 16"/>
+          <p:cNvSpPr txBox="1"/>
+          <p:nvPr/>
+        </p:nvSpPr>
+        <p:spPr>
+          <a:xfrm>
+            <a:off x="877824" y="4421124"/>
+            <a:ext cx="3328416" cy="308864"/>
+          </a:xfrm>
+          <a:prstGeom prst="rect">
+            <a:avLst/>
+          </a:prstGeom>
+          <a:noFill/>
+        </p:spPr>
+        <p:txBody>
+          <a:bodyPr wrap="square" lIns="0" tIns="0" rIns="0" bIns="0" anchor="t">
+            <a:spAutoFit/>
+          </a:bodyPr>
+          <a:lstStyle/>
+          <a:p>
+            <a:pPr algn="l"/>
+            <a:r>
+              <a:rPr lang="fr-FR" sz="950" b="1" i="0" dirty="0">
+                <a:solidFill>
+                  <a:srgbClr val="1F2A37"/>
+                </a:solidFill>
+                <a:latin typeface="Roboto"/>
+              </a:rPr>
+              <a:t xml:space="preserve">« Ajouter des images, vidéos ou sons »</a:t>
+            </a:r>
+            <a:r>
+              <a:rPr lang="fr-FR" sz="950" b="0" i="0" dirty="0">
+                <a:solidFill>
+                  <a:srgbClr val="1F2A37"/>
+                </a:solidFill>
+                <a:latin typeface="Roboto"/>
+              </a:rPr>
+              <a:t xml:space="preserve"> : plusieurs fichiers à la fois, ou glissez-les sur la vitrine.</a:t>
+            </a:r>
+          </a:p>
+        </p:txBody>
+      </p:sp>
+      <p:pic>
+        <p:nvPicPr>
+          <p:cNvPr id="7" name="Picture 6" descr="Galerie média vue par un visiteur : carrousel, légende sous le média"/>
+          <p:cNvPicPr>
+            <a:picLocks noChangeAspect="1"/>
+          </p:cNvPicPr>
+          <p:nvPr/>
+        </p:nvPicPr>
+        <p:blipFill>
+          <a:blip r:embed="rId4"/>
+          <a:stretch>
+            <a:fillRect/>
+          </a:stretch>
+        </p:blipFill>
+        <p:spPr>
+          <a:xfrm>
+            <a:off x="4480560" y="1188720"/>
+            <a:ext cx="2286000" cy="1207698"/>
+          </a:xfrm>
+          <a:prstGeom prst="rect">
+            <a:avLst/>
+          </a:prstGeom>
+          <a:ln w="9525">
+            <a:solidFill>
+              <a:srgbClr val="D5DCE4"/>
+            </a:solidFill>
+          </a:ln>
+        </p:spPr>
+      </p:pic>
+      <p:sp>
+        <p:nvSpPr>
+          <p:cNvPr id="20" name="TextBox 19"/>
+          <p:cNvSpPr txBox="1"/>
+          <p:nvPr/>
+        </p:nvSpPr>
+        <p:spPr>
+          <a:xfrm>
+            <a:off x="6949440" y="1188720"/>
+            <a:ext cx="1645920" cy="1207698"/>
+          </a:xfrm>
+          <a:prstGeom prst="rect">
+            <a:avLst/>
+          </a:prstGeom>
+          <a:noFill/>
+        </p:spPr>
+        <p:txBody>
+          <a:bodyPr wrap="square" lIns="0" tIns="0" rIns="0" bIns="0" anchor="t">
+            <a:spAutoFit/>
+          </a:bodyPr>
+          <a:lstStyle/>
+          <a:p>
+            <a:pPr algn="l">
+              <a:spcAft>
+                <a:spcPts val="400"/>
+              </a:spcAft>
+            </a:pPr>
+            <a:r>
+              <a:rPr lang="fr-FR" sz="950" b="1" i="0" dirty="0">
+                <a:solidFill>
+                  <a:srgbClr val="1F2A37"/>
+                </a:solidFill>
+                <a:latin typeface="Roboto"/>
+              </a:rPr>
+              <a:t xml:space="preserve">Ce que voit le visiteur</a:t>
+            </a:r>
+          </a:p>
+          <a:p>
+            <a:pPr algn="l"/>
+            <a:r>
+              <a:rPr lang="fr-FR" sz="950" b="0" i="0" dirty="0">
+                <a:solidFill>
+                  <a:srgbClr val="1F2A37"/>
+                </a:solidFill>
+                <a:latin typeface="Roboto"/>
+              </a:rPr>
+              <a:t xml:space="preserve">Légende à gauche, à droite ou sous le média. Sur un écran étroit, elle passe dessous.</a:t>
+            </a:r>
+          </a:p>
+        </p:txBody>
+      </p:sp>
+      <p:sp>
+        <p:nvSpPr>
+          <p:cNvPr id="30" name="Rounded Rectangle 29"/>
+          <p:cNvSpPr/>
+          <p:nvPr/>
+        </p:nvSpPr>
+        <p:spPr>
+          <a:xfrm>
+            <a:off x="4480560" y="2606040"/>
+            <a:ext cx="4114800" cy="1600200"/>
+          </a:xfrm>
+          <a:prstGeom prst="roundRect">
+            <a:avLst>
+              <a:gd name="adj" fmla="val 6000"/>
+            </a:avLst>
+          </a:prstGeom>
+          <a:solidFill>
+            <a:srgbClr val="EEF3F8"/>
+          </a:solidFill>
+          <a:ln>
+            <a:noFill/>
+          </a:ln>
+          <a:effectLst/>
+        </p:spPr>
+        <p:style>
+          <a:lnRef idx="1">
+            <a:schemeClr val="accent1"/>
+          </a:lnRef>
+          <a:fillRef idx="3">
+            <a:schemeClr val="accent1"/>
+          </a:fillRef>
+          <a:effectRef idx="0">
+            <a:schemeClr val="accent1"/>
+          </a:effectRef>
+          <a:fontRef idx="minor">
+            <a:schemeClr val="lt1"/>
+          </a:fontRef>
+        </p:style>
+        <p:txBody>
+          <a:bodyPr rtlCol="0" anchor="ctr"/>
+          <a:lstStyle/>
+          <a:p>
+            <a:pPr algn="ctr"/>
+            <a:endParaRPr lang="fr-FR"/>
+          </a:p>
+        </p:txBody>
+      </p:sp>
+      <p:sp>
+        <p:nvSpPr>
+          <p:cNvPr id="31" name="TextBox 30"/>
+          <p:cNvSpPr txBox="1"/>
+          <p:nvPr/>
+        </p:nvSpPr>
+        <p:spPr>
+          <a:xfrm>
+            <a:off x="4663440" y="2743200"/>
+            <a:ext cx="3749040" cy="1325880"/>
+          </a:xfrm>
+          <a:prstGeom prst="rect">
+            <a:avLst/>
+          </a:prstGeom>
+          <a:noFill/>
+        </p:spPr>
+        <p:txBody>
+          <a:bodyPr wrap="square" lIns="0" tIns="0" rIns="0" bIns="0" anchor="t">
+            <a:spAutoFit/>
+          </a:bodyPr>
+          <a:lstStyle/>
+          <a:p>
+            <a:pPr algn="l">
+              <a:spcAft>
+                <a:spcPts val="400"/>
+              </a:spcAft>
+            </a:pPr>
+            <a:r>
+              <a:rPr lang="fr-FR" sz="950" b="1" i="0" dirty="0">
+                <a:solidFill>
+                  <a:srgbClr val="1F2A37"/>
+                </a:solidFill>
+                <a:latin typeface="Roboto"/>
+              </a:rPr>
+              <a:t xml:space="preserve">Une vidéo trop lourde ? Microsoft Stream</a:t>
+            </a:r>
+          </a:p>
+          <a:p>
+            <a:pPr algn="l">
+              <a:spcAft>
+                <a:spcPts val="400"/>
+              </a:spcAft>
+            </a:pPr>
+            <a:r>
+              <a:rPr lang="fr-FR" sz="950" b="0" i="0" dirty="0">
+                <a:solidFill>
+                  <a:srgbClr val="1F2A37"/>
+                </a:solidFill>
+                <a:latin typeface="Roboto"/>
+              </a:rPr>
+              <a:t xml:space="preserve">Collez le lien ou, pour la lire dans la vitrine, le code d’intégration (dans Stream : Partager › Incorporer).</a:t>
+            </a:r>
+          </a:p>
+          <a:p>
+            <a:pPr algn="l">
+              <a:spcAft>
+                <a:spcPts val="400"/>
+              </a:spcAft>
+            </a:pPr>
+            <a:r>
+              <a:rPr lang="fr-FR" sz="950" b="1" i="0" dirty="0">
+                <a:solidFill>
+                  <a:srgbClr val="1F2A37"/>
+                </a:solidFill>
+                <a:latin typeface="Roboto"/>
+              </a:rPr>
+              <a:t xml:space="preserve">Important : partagez la vidéo dans Stream avec les visiteurs de la vitrine, sinon ils ne la verront pas.</a:t>
+            </a:r>
+          </a:p>
+          <a:p>
+            <a:pPr algn="l"/>
+            <a:r>
+              <a:rPr lang="fr-FR" sz="950" b="0" i="0" dirty="0">
+                <a:solidFill>
+                  <a:srgbClr val="1F2A37"/>
+                </a:solidFill>
+                <a:latin typeface="Roboto"/>
+              </a:rPr>
+              <a:t xml:space="preserve">Accès : « Ajouter une section ici » → « Galerie média ».</a:t>
+            </a:r>
+          </a:p>
+        </p:txBody>
+      </p:sp>
+    </p:spTree>
+  </p:cSld>
+  <p:clrMapOvr>
+    <a:masterClrMapping/>
+  </p:clrMapOvr>
+</p:sld>
+</file>
+
 <file path=ppt/slides/slide6.xml><?xml version="1.0" encoding="utf-8"?>
 <p:sld xmlns:a="http://schemas.openxmlformats.org/drawingml/2006/main" xmlns:r="http://schemas.openxmlformats.org/officeDocument/2006/relationships" xmlns:p="http://schemas.openxmlformats.org/presentationml/2006/main">
   <p:cSld>
@@ -50729,6 +51624,182 @@
         <p:spPr>
           <a:xfrm>
             <a:off x="8001000" y="2240279"/>
+            <a:ext cx="594360" cy="228600"/>
+          </a:xfrm>
+          <a:prstGeom prst="rect">
+            <a:avLst/>
+          </a:prstGeom>
+          <a:noFill/>
+        </p:spPr>
+        <p:txBody>
+          <a:bodyPr wrap="square" lIns="0" tIns="0" rIns="0" bIns="0" anchor="t">
+            <a:spAutoFit/>
+          </a:bodyPr>
+          <a:lstStyle/>
+          <a:p>
+            <a:pPr algn="r"/>
+            <a:r>
+              <a:rPr sz="950" b="1" i="0">
+                <a:solidFill>
+                  <a:srgbClr val="0061B0"/>
+                </a:solidFill>
+                <a:latin typeface="Roboto"/>
+              </a:rPr>
+              <a:t>Voir →</a:t>
+            </a:r>
+          </a:p>
+        </p:txBody>
+      </p:sp>
+      <p:sp>
+        <p:nvSpPr>
+          <p:cNvPr id="126" name="Rectangle 25">
+            <a:extLst>
+              <a:ext uri="{FF2B5EF4-FFF2-40B4-BE49-F238E27FC236}">
+                <a16:creationId xmlns:a16="http://schemas.microsoft.com/office/drawing/2014/main" id="{6B9CF83B-EC74-8BD5-6E88-384C3B07B37F}"/>
+              </a:ext>
+            </a:extLst>
+          </p:cNvPr>
+          <p:cNvSpPr/>
+          <p:nvPr/>
+        </p:nvSpPr>
+        <p:spPr>
+          <a:xfrm>
+            <a:off x="457200" y="2477943"/>
+            <a:ext cx="8229600" cy="274320"/>
+          </a:xfrm>
+          <a:prstGeom prst="rect">
+            <a:avLst/>
+          </a:prstGeom>
+          <a:solidFill>
+            <a:srgbClr val="EEF3F8"/>
+          </a:solidFill>
+          <a:ln>
+            <a:noFill/>
+          </a:ln>
+          <a:effectLst/>
+        </p:spPr>
+        <p:style>
+          <a:lnRef idx="1">
+            <a:schemeClr val="accent1"/>
+          </a:lnRef>
+          <a:fillRef idx="3">
+            <a:schemeClr val="accent1"/>
+          </a:fillRef>
+          <a:effectRef idx="0">
+            <a:schemeClr val="accent1"/>
+          </a:effectRef>
+          <a:fontRef idx="minor">
+            <a:schemeClr val="lt1"/>
+          </a:fontRef>
+        </p:style>
+        <p:txBody>
+          <a:bodyPr rtlCol="0" anchor="ctr"/>
+          <a:lstStyle/>
+          <a:p>
+            <a:pPr algn="ctr"/>
+            <a:endParaRPr/>
+          </a:p>
+        </p:txBody>
+      </p:sp>
+      <p:sp>
+        <p:nvSpPr>
+          <p:cNvPr id="127" name="TextBox 26">
+            <a:hlinkClick r:id="rId6" action="ppaction://hlinksldjump"/>
+            <a:extLst>
+              <a:ext uri="{FF2B5EF4-FFF2-40B4-BE49-F238E27FC236}">
+                <a16:creationId xmlns:a16="http://schemas.microsoft.com/office/drawing/2014/main" id="{AF6CFE72-20E5-2D59-19AC-984A171DDC59}"/>
+              </a:ext>
+            </a:extLst>
+          </p:cNvPr>
+          <p:cNvSpPr txBox="1"/>
+          <p:nvPr/>
+        </p:nvSpPr>
+        <p:spPr>
+          <a:xfrm>
+            <a:off x="548640" y="2514599"/>
+            <a:ext cx="3017520" cy="228600"/>
+          </a:xfrm>
+          <a:prstGeom prst="rect">
+            <a:avLst/>
+          </a:prstGeom>
+          <a:noFill/>
+        </p:spPr>
+        <p:txBody>
+          <a:bodyPr wrap="square" lIns="0" tIns="0" rIns="0" bIns="0" anchor="t">
+            <a:spAutoFit/>
+          </a:bodyPr>
+          <a:lstStyle/>
+          <a:p>
+            <a:pPr algn="l"/>
+            <a:r>
+              <a:rPr sz="950" b="1" i="0">
+                <a:solidFill>
+                  <a:srgbClr val="003059"/>
+                </a:solidFill>
+                <a:latin typeface="Roboto"/>
+              </a:rPr>
+              <a:t>Ajouter des images ou des vidéos</a:t>
+            </a:r>
+          </a:p>
+        </p:txBody>
+      </p:sp>
+      <p:sp>
+        <p:nvSpPr>
+          <p:cNvPr id="128" name="TextBox 27">
+            <a:extLst>
+              <a:ext uri="{FF2B5EF4-FFF2-40B4-BE49-F238E27FC236}">
+                <a16:creationId xmlns:a16="http://schemas.microsoft.com/office/drawing/2014/main" id="{F5F6BB4A-7940-7C79-F241-A8E9DDF032AE}"/>
+              </a:ext>
+            </a:extLst>
+          </p:cNvPr>
+          <p:cNvSpPr txBox="1"/>
+          <p:nvPr/>
+        </p:nvSpPr>
+        <p:spPr>
+          <a:xfrm>
+            <a:off x="3657600" y="2514599"/>
+            <a:ext cx="4206240" cy="228600"/>
+          </a:xfrm>
+          <a:prstGeom prst="rect">
+            <a:avLst/>
+          </a:prstGeom>
+          <a:noFill/>
+        </p:spPr>
+        <p:txBody>
+          <a:bodyPr wrap="square" lIns="0" tIns="0" rIns="0" bIns="0" anchor="t">
+            <a:spAutoFit/>
+          </a:bodyPr>
+          <a:lstStyle/>
+          <a:p>
+            <a:pPr algn="l"/>
+            <a:r>
+              <a:rPr sz="950" b="0" i="0">
+                <a:solidFill>
+                  <a:srgbClr val="1F2A37"/>
+                </a:solidFill>
+                <a:latin typeface="Roboto"/>
+              </a:rPr>
+              <a:t>« Ajouter une section ici » → « Galerie média »</a:t>
+            </a:r>
+          </a:p>
+        </p:txBody>
+      </p:sp>
+      <p:sp>
+        <p:nvSpPr>
+          <p:cNvPr id="129" name="TextBox 28">
+            <a:hlinkClick r:id="rId6" action="ppaction://hlinksldjump"/>
+            <a:extLst>
+              <a:ext uri="{FF2B5EF4-FFF2-40B4-BE49-F238E27FC236}">
+                <a16:creationId xmlns:a16="http://schemas.microsoft.com/office/drawing/2014/main" id="{24DD8798-BEF6-00F1-E6CA-A0A65F38743A}"/>
+              </a:ext>
+            </a:extLst>
+          </p:cNvPr>
+          <p:cNvSpPr txBox="1"/>
+          <p:nvPr/>
+        </p:nvSpPr>
+        <p:spPr>
+          <a:xfrm>
+            <a:off x="8001000" y="2514599"/>
             <a:ext cx="594360" cy="228600"/>
           </a:xfrm>
           <a:prstGeom prst="rect">

</xml_diff>

<commit_message>
Manuel chef de projet : modifier le document d'une visionneuse dans Office
- « Régler une section » : encadré sur « Modifier dans PowerPoint/Word/Excel en
  ligne », « Ouvrir dans l'application », « Actualiser l'aperçu », et rappel que le
  fichier est modifié sur place, visible des lecteurs sans publier.
- « Entrées par objectif » : ligne « Modifier le document d'une visionneuse ».

Co-Authored-By: Claude Opus 5.5 <noreply@anthropic.com>
Claude-Session: https://claude.ai/code/session_013ggHK1CDXnG5bFYyYmTXJ5
</commit_message>
<xml_diff>
--- a/docs/Project Navigator _ Manuel Chef de Project.pptx
+++ b/docs/Project Navigator _ Manuel Chef de Project.pptx
@@ -24521,6 +24521,172 @@
           </a:p>
         </p:txBody>
       </p:sp>
+      <p:sp>
+        <p:nvSpPr>
+          <p:cNvPr id="15" name="Rounded Rectangle 30"/>
+          <p:cNvSpPr/>
+          <p:nvPr/>
+        </p:nvSpPr>
+        <p:spPr>
+          <a:xfrm>
+            <a:off x="5394960" y="2514600"/>
+            <a:ext cx="3246120" cy="1828800"/>
+          </a:xfrm>
+          <a:prstGeom prst="roundRect">
+            <a:avLst>
+              <a:gd name="adj" fmla="val 6000"/>
+            </a:avLst>
+          </a:prstGeom>
+          <a:solidFill>
+            <a:srgbClr val="EEF3F8"/>
+          </a:solidFill>
+          <a:ln>
+            <a:noFill/>
+          </a:ln>
+          <a:effectLst/>
+        </p:spPr>
+        <p:style>
+          <a:lnRef idx="1">
+            <a:schemeClr val="accent1"/>
+          </a:lnRef>
+          <a:fillRef idx="3">
+            <a:schemeClr val="accent1"/>
+          </a:fillRef>
+          <a:effectRef idx="0">
+            <a:schemeClr val="accent1"/>
+          </a:effectRef>
+          <a:fontRef idx="minor">
+            <a:schemeClr val="lt1"/>
+          </a:fontRef>
+        </p:style>
+        <p:txBody>
+          <a:bodyPr rtlCol="0" anchor="ctr"/>
+          <a:lstStyle/>
+          <a:p>
+            <a:pPr algn="ctr"/>
+            <a:endParaRPr/>
+          </a:p>
+        </p:txBody>
+      </p:sp>
+      <p:sp>
+        <p:nvSpPr>
+          <p:cNvPr id="16" name="TextBox 31"/>
+          <p:cNvSpPr txBox="1"/>
+          <p:nvPr/>
+        </p:nvSpPr>
+        <p:spPr>
+          <a:xfrm>
+            <a:off x="5532120" y="2633472"/>
+            <a:ext cx="2971800" cy="1600200"/>
+          </a:xfrm>
+          <a:prstGeom prst="rect">
+            <a:avLst/>
+          </a:prstGeom>
+          <a:noFill/>
+        </p:spPr>
+        <p:txBody>
+          <a:bodyPr wrap="square" lIns="0" tIns="0" rIns="0" bIns="0" anchor="t">
+            <a:spAutoFit/>
+          </a:bodyPr>
+          <a:lstStyle/>
+          <a:p>
+            <a:pPr algn="l">
+              <a:spcAft>
+                <a:spcPts val="400"/>
+              </a:spcAft>
+            </a:pPr>
+            <a:r>
+              <a:rPr lang="fr-FR" sz="950" b="1" i="0" dirty="0">
+                <a:solidFill>
+                  <a:srgbClr val="1F2A37"/>
+                </a:solidFill>
+                <a:latin typeface="Roboto"/>
+              </a:rPr>
+              <a:t xml:space="preserve">Visionneuse : modifier le document</a:t>
+            </a:r>
+          </a:p>
+          <a:p>
+            <a:pPr algn="l">
+              <a:spcAft>
+                <a:spcPts val="400"/>
+              </a:spcAft>
+            </a:pPr>
+            <a:r>
+              <a:rPr lang="fr-FR" sz="950" b="0" i="0" dirty="0">
+                <a:solidFill>
+                  <a:srgbClr val="1F2A37"/>
+                </a:solidFill>
+                <a:latin typeface="Roboto"/>
+              </a:rPr>
+              <a:t xml:space="preserve">Sur un fichier PowerPoint, Word ou Excel déposé, le mode édition propose </a:t>
+            </a:r>
+            <a:r>
+              <a:rPr lang="fr-FR" sz="950" b="1" i="0" dirty="0">
+                <a:solidFill>
+                  <a:srgbClr val="1F2A37"/>
+                </a:solidFill>
+                <a:latin typeface="Roboto"/>
+              </a:rPr>
+              <a:t xml:space="preserve">« Modifier dans PowerPoint en ligne »</a:t>
+            </a:r>
+            <a:r>
+              <a:rPr lang="fr-FR" sz="950" b="0" i="0" dirty="0">
+                <a:solidFill>
+                  <a:srgbClr val="1F2A37"/>
+                </a:solidFill>
+                <a:latin typeface="Roboto"/>
+              </a:rPr>
+              <a:t xml:space="preserve"> (ou Word, Excel) et </a:t>
+            </a:r>
+            <a:r>
+              <a:rPr lang="fr-FR" sz="950" b="1" i="0" dirty="0">
+                <a:solidFill>
+                  <a:srgbClr val="1F2A37"/>
+                </a:solidFill>
+                <a:latin typeface="Roboto"/>
+              </a:rPr>
+              <a:t xml:space="preserve">« Ouvrir dans l’application PowerPoint »</a:t>
+            </a:r>
+            <a:r>
+              <a:rPr lang="fr-FR" sz="950" b="0" i="0" dirty="0">
+                <a:solidFill>
+                  <a:srgbClr val="1F2A37"/>
+                </a:solidFill>
+                <a:latin typeface="Roboto"/>
+              </a:rPr>
+              <a:t xml:space="preserve">.</a:t>
+            </a:r>
+          </a:p>
+          <a:p>
+            <a:pPr algn="l">
+              <a:spcAft>
+                <a:spcPts val="400"/>
+              </a:spcAft>
+            </a:pPr>
+            <a:r>
+              <a:rPr lang="fr-FR" sz="950" b="0" i="0" dirty="0">
+                <a:solidFill>
+                  <a:srgbClr val="1F2A37"/>
+                </a:solidFill>
+                <a:latin typeface="Roboto"/>
+              </a:rPr>
+              <a:t xml:space="preserve">De retour sur la vitrine, l’aperçu se met à jour ; sinon, « Actualiser l’aperçu ».</a:t>
+            </a:r>
+          </a:p>
+          <a:p>
+            <a:pPr algn="l"/>
+            <a:r>
+              <a:rPr lang="fr-FR" sz="950" b="1" i="0" dirty="0">
+                <a:solidFill>
+                  <a:srgbClr val="1F2A37"/>
+                </a:solidFill>
+                <a:latin typeface="Roboto"/>
+              </a:rPr>
+              <a:t xml:space="preserve">Attention : le fichier est modifié là où il est stocké, les lecteurs voient les changements tout de suite, sans « Publier ».</a:t>
+            </a:r>
+          </a:p>
+        </p:txBody>
+      </p:sp>
     </p:spTree>
   </p:cSld>
   <p:clrMapOvr>
@@ -51800,6 +51966,131 @@
         <p:spPr>
           <a:xfrm>
             <a:off x="8001000" y="2514599"/>
+            <a:ext cx="594360" cy="228600"/>
+          </a:xfrm>
+          <a:prstGeom prst="rect">
+            <a:avLst/>
+          </a:prstGeom>
+          <a:noFill/>
+        </p:spPr>
+        <p:txBody>
+          <a:bodyPr wrap="square" lIns="0" tIns="0" rIns="0" bIns="0" anchor="t">
+            <a:spAutoFit/>
+          </a:bodyPr>
+          <a:lstStyle/>
+          <a:p>
+            <a:pPr algn="r"/>
+            <a:r>
+              <a:rPr sz="950" b="1" i="0">
+                <a:solidFill>
+                  <a:srgbClr val="0061B0"/>
+                </a:solidFill>
+                <a:latin typeface="Roboto"/>
+              </a:rPr>
+              <a:t>Voir →</a:t>
+            </a:r>
+          </a:p>
+        </p:txBody>
+      </p:sp>
+      <p:sp>
+        <p:nvSpPr>
+          <p:cNvPr id="130" name="TextBox 32">
+            <a:hlinkClick r:id="rId7" action="ppaction://hlinksldjump"/>
+            <a:extLst>
+              <a:ext uri="{FF2B5EF4-FFF2-40B4-BE49-F238E27FC236}">
+                <a16:creationId xmlns:a16="http://schemas.microsoft.com/office/drawing/2014/main" id="{AF6CFE72-20E5-2D59-19AC-984A171DDC59}"/>
+              </a:ext>
+            </a:extLst>
+          </p:cNvPr>
+          <p:cNvSpPr txBox="1"/>
+          <p:nvPr/>
+        </p:nvSpPr>
+        <p:spPr>
+          <a:xfrm>
+            <a:off x="548640" y="2788919"/>
+            <a:ext cx="3017520" cy="228600"/>
+          </a:xfrm>
+          <a:prstGeom prst="rect">
+            <a:avLst/>
+          </a:prstGeom>
+          <a:noFill/>
+        </p:spPr>
+        <p:txBody>
+          <a:bodyPr wrap="square" lIns="0" tIns="0" rIns="0" bIns="0" anchor="t">
+            <a:spAutoFit/>
+          </a:bodyPr>
+          <a:lstStyle/>
+          <a:p>
+            <a:pPr algn="l"/>
+            <a:r>
+              <a:rPr sz="950" b="1" i="0">
+                <a:solidFill>
+                  <a:srgbClr val="003059"/>
+                </a:solidFill>
+                <a:latin typeface="Roboto"/>
+              </a:rPr>
+              <a:t>Modifier le document d’une visionneuse</a:t>
+            </a:r>
+          </a:p>
+        </p:txBody>
+      </p:sp>
+      <p:sp>
+        <p:nvSpPr>
+          <p:cNvPr id="131" name="TextBox 33">
+            <a:extLst>
+              <a:ext uri="{FF2B5EF4-FFF2-40B4-BE49-F238E27FC236}">
+                <a16:creationId xmlns:a16="http://schemas.microsoft.com/office/drawing/2014/main" id="{F5F6BB4A-7940-7C79-F241-A8E9DDF032AE}"/>
+              </a:ext>
+            </a:extLst>
+          </p:cNvPr>
+          <p:cNvSpPr txBox="1"/>
+          <p:nvPr/>
+        </p:nvSpPr>
+        <p:spPr>
+          <a:xfrm>
+            <a:off x="3657600" y="2788919"/>
+            <a:ext cx="4206240" cy="228600"/>
+          </a:xfrm>
+          <a:prstGeom prst="rect">
+            <a:avLst/>
+          </a:prstGeom>
+          <a:noFill/>
+        </p:spPr>
+        <p:txBody>
+          <a:bodyPr wrap="square" lIns="0" tIns="0" rIns="0" bIns="0" anchor="t">
+            <a:spAutoFit/>
+          </a:bodyPr>
+          <a:lstStyle/>
+          <a:p>
+            <a:pPr algn="l"/>
+            <a:r>
+              <a:rPr sz="950" b="0" i="0">
+                <a:solidFill>
+                  <a:srgbClr val="1F2A37"/>
+                </a:solidFill>
+                <a:latin typeface="Roboto"/>
+              </a:rPr>
+              <a:t>Vitrine → « Modifier » → « Modifier dans … en ligne »</a:t>
+            </a:r>
+          </a:p>
+        </p:txBody>
+      </p:sp>
+      <p:sp>
+        <p:nvSpPr>
+          <p:cNvPr id="132" name="TextBox 34">
+            <a:hlinkClick r:id="rId7" action="ppaction://hlinksldjump"/>
+            <a:extLst>
+              <a:ext uri="{FF2B5EF4-FFF2-40B4-BE49-F238E27FC236}">
+                <a16:creationId xmlns:a16="http://schemas.microsoft.com/office/drawing/2014/main" id="{24DD8798-BEF6-00F1-E6CA-A0A65F38743A}"/>
+              </a:ext>
+            </a:extLst>
+          </p:cNvPr>
+          <p:cNvSpPr txBox="1"/>
+          <p:nvPr/>
+        </p:nvSpPr>
+        <p:spPr>
+          <a:xfrm>
+            <a:off x="8001000" y="2788919"/>
             <a:ext cx="594360" cy="228600"/>
           </a:xfrm>
           <a:prstGeom prst="rect">

</xml_diff>